<commit_message>
PowerPoint: corrige solape en portada y diapositiva 5, añade comprobación
- Portada: el título ya no pisa el subtítulo
- Diapositiva 5: título algo menor para no invadir las etiquetas
- Marca de verificación con fuente de símbolos
- check_pptx.py: comprueba desbordes de texto y renderiza una vista previa

Co-Authored-By: Claude Sonnet 5.5 <noreply@anthropic.com>
</commit_message>
<xml_diff>
--- a/exportacion/Presentacion_Mejora_Pistas_Multideporte.pptx
+++ b/exportacion/Presentacion_Mejora_Pistas_Multideporte.pptx
@@ -4414,7 +4414,7 @@
         </p:nvSpPr>
         <p:spPr>
           <a:xfrm>
-            <a:off x="812800" y="3136900"/>
+            <a:off x="812800" y="2959100"/>
             <a:ext cx="6985000" cy="228600"/>
           </a:xfrm>
           <a:prstGeom prst="rect">
@@ -4453,8 +4453,8 @@
         </p:nvSpPr>
         <p:spPr>
           <a:xfrm>
-            <a:off x="812800" y="3492500"/>
-            <a:ext cx="7302500" cy="1778000"/>
+            <a:off x="812800" y="3302000"/>
+            <a:ext cx="7302500" cy="2032000"/>
           </a:xfrm>
           <a:prstGeom prst="rect">
             <a:avLst/>
@@ -4492,7 +4492,7 @@
         </p:nvSpPr>
         <p:spPr>
           <a:xfrm>
-            <a:off x="812800" y="5372100"/>
+            <a:off x="812800" y="5511800"/>
             <a:ext cx="6096000" cy="698500"/>
           </a:xfrm>
           <a:prstGeom prst="rect">
@@ -7304,7 +7304,7 @@
               </a:lnSpc>
             </a:pPr>
             <a:r>
-              <a:rPr sz="4800" b="1">
+              <a:rPr sz="4400" b="1">
                 <a:solidFill>
                   <a:srgbClr val="F7F5F0"/>
                 </a:solidFill>
@@ -9862,7 +9862,7 @@
                 <a:solidFill>
                   <a:srgbClr val="10243A"/>
                 </a:solidFill>
-                <a:latin typeface="Arial Narrow"/>
+                <a:latin typeface="Segoe UI Symbol"/>
               </a:rPr>
               <a:t>✓</a:t>
             </a:r>
@@ -9993,7 +9993,7 @@
                 <a:solidFill>
                   <a:srgbClr val="10243A"/>
                 </a:solidFill>
-                <a:latin typeface="Arial Narrow"/>
+                <a:latin typeface="Segoe UI Symbol"/>
               </a:rPr>
               <a:t>✓</a:t>
             </a:r>
@@ -10124,7 +10124,7 @@
                 <a:solidFill>
                   <a:srgbClr val="10243A"/>
                 </a:solidFill>
-                <a:latin typeface="Arial Narrow"/>
+                <a:latin typeface="Segoe UI Symbol"/>
               </a:rPr>
               <a:t>✓</a:t>
             </a:r>
@@ -10255,7 +10255,7 @@
                 <a:solidFill>
                   <a:srgbClr val="10243A"/>
                 </a:solidFill>
-                <a:latin typeface="Arial Narrow"/>
+                <a:latin typeface="Segoe UI Symbol"/>
               </a:rPr>
               <a:t>✓</a:t>
             </a:r>

</xml_diff>

<commit_message>
Presentación: 90 m en atletismo, nueva diapositiva de superficies y fases
- Atletismo: 90 m de pista de velocidad (60 m + 30 m de frenada)
- Nueva diapositiva "Dos superficies, cada una para lo suyo":
  tartán sintético (atletismo) y PVC o resinas (pistas multideporte)
- Ejecución por fases: 1 módulo de atletismo, 2 pistas multideporte,
  3 cubierta y cerramiento
- Exportaciones PPTX y PDF (completo y comprimido) actualizadas

Co-Authored-By: Claude Sonnet 5.5 <noreply@anthropic.com>
</commit_message>
<xml_diff>
--- a/exportacion/Presentacion_Mejora_Pistas_Multideporte.pptx
+++ b/exportacion/Presentacion_Mejora_Pistas_Multideporte.pptx
@@ -16,6 +16,7 @@
     <p:sldId id="264" r:id="rId16"/>
     <p:sldId id="265" r:id="rId17"/>
     <p:sldId id="266" r:id="rId18"/>
+    <p:sldId id="267" r:id="rId19"/>
   </p:sldIdLst>
   <p:sldSz cx="12192000" cy="6858000" type="screen4x3"/>
   <p:notesSz cx="6858000" cy="9144000"/>
@@ -582,7 +583,7 @@
           <a:lstStyle/>
           <a:p>
             <a:r>
-              <a:t>Los beneficiarios son muy distintos: clubes y escuelas, atletas que quieren tecnificarse, organizadores de competiciones y cualquier vecino que quiera hacer deporte.</a:t>
+              <a:t>La nave también se renueva: nueva cubierta aislante, un cerramiento que deja pasar la luz, y un entorno exterior más cómodo y accesible. El resultado es un espacio protegido de la lluvia, el frío, el viento y las aves.</a:t>
             </a:r>
           </a:p>
         </p:txBody>
@@ -652,6 +653,76 @@
           <a:lstStyle/>
           <a:p>
             <a:r>
+              <a:t>Los beneficiarios son muy distintos: clubes y escuelas, atletas que quieren tecnificarse, organizadores de competiciones y cualquier vecino que quiera hacer deporte.</a:t>
+            </a:r>
+          </a:p>
+        </p:txBody>
+      </p:sp>
+      <p:sp>
+        <p:nvSpPr>
+          <p:cNvPr id="4" name="Slide Number Placeholder 3"/>
+          <p:cNvSpPr>
+            <a:spLocks noGrp="1"/>
+          </p:cNvSpPr>
+          <p:nvPr>
+            <p:ph type="sldNum" idx="5" sz="quarter"/>
+          </p:nvPr>
+        </p:nvSpPr>
+        <p:spPr/>
+      </p:sp>
+    </p:spTree>
+  </p:cSld>
+  <p:clrMapOvr>
+    <a:masterClrMapping/>
+  </p:clrMapOvr>
+</p:notes>
+</file>
+
+<file path=ppt/notesSlides/notesSlide12.xml><?xml version="1.0" encoding="utf-8"?>
+<p:notes xmlns:a="http://schemas.openxmlformats.org/drawingml/2006/main" xmlns:p="http://schemas.openxmlformats.org/presentationml/2006/main" xmlns:r="http://schemas.openxmlformats.org/officeDocument/2006/relationships">
+  <p:cSld>
+    <p:spTree>
+      <p:nvGrpSpPr>
+        <p:cNvPr id="1" name=""/>
+        <p:cNvGrpSpPr/>
+        <p:nvPr/>
+      </p:nvGrpSpPr>
+      <p:grpSpPr>
+        <a:xfrm>
+          <a:off x="0" y="0"/>
+          <a:ext cx="0" cy="0"/>
+          <a:chOff x="0" y="0"/>
+          <a:chExt cx="0" cy="0"/>
+        </a:xfrm>
+      </p:grpSpPr>
+      <p:sp>
+        <p:nvSpPr>
+          <p:cNvPr id="2" name="Slide Image Placeholder 1"/>
+          <p:cNvSpPr>
+            <a:spLocks noGrp="1"/>
+          </p:cNvSpPr>
+          <p:nvPr>
+            <p:ph type="sldImg" idx="2"/>
+          </p:nvPr>
+        </p:nvSpPr>
+        <p:spPr/>
+      </p:sp>
+      <p:sp>
+        <p:nvSpPr>
+          <p:cNvPr id="3" name="Notes Placeholder 2"/>
+          <p:cNvSpPr>
+            <a:spLocks noGrp="1"/>
+          </p:cNvSpPr>
+          <p:nvPr>
+            <p:ph type="body" idx="3" sz="quarter"/>
+          </p:nvPr>
+        </p:nvSpPr>
+        <p:spPr/>
+        <p:txBody>
+          <a:bodyPr/>
+          <a:lstStyle/>
+          <a:p>
+            <a:r>
               <a:t>Cerramos con la idea central: un espacio cubierto que permite practicar atletismo y deporte todo el año. Gracias.</a:t>
             </a:r>
           </a:p>
@@ -1072,7 +1143,7 @@
           <a:lstStyle/>
           <a:p>
             <a:r>
-              <a:t>Este es el corazón del proyecto: un módulo de atletismo cubierto, con ocho calles de sesenta metros y zonas de salto. Se entrega homologado por la Real Federación Española de Atletismo. Permite entrenar y tecnificar todo el año, llueva o haga frío.</a:t>
+              <a:t>Este es el corazón del proyecto: un módulo de atletismo cubierto, con ocho calles de noventa metros, zona de frenada incluida, y zonas de salto. Se entrega homologado por la Real Federación Española de Atletismo. Permite entrenar y tecnificar todo el año, llueva o haga frío.</a:t>
             </a:r>
           </a:p>
         </p:txBody>
@@ -1212,7 +1283,7 @@
           <a:lstStyle/>
           <a:p>
             <a:r>
-              <a:t>La nave también se renueva: nueva cubierta aislante, un cerramiento que deja pasar la luz, y un entorno exterior más cómodo y accesible. El resultado es un espacio protegido de la lluvia, el frío, el viento y las aves.</a:t>
+              <a:t>Cada zona lleva su propia superficie. En atletismo, un tartán sintético poroso, aplicado in situ y homologado por la RFEA. En las pistas multideporte, un pavimento de PVC o resinas, como el de los pabellones cubiertos. Como las superficies son independientes, la obra puede hacerse por fases y adaptar el orden. El proyecto estima unos seis meses en total.</a:t>
             </a:r>
           </a:p>
         </p:txBody>
@@ -4537,6 +4608,620 @@
     <p:bg>
       <p:bgPr>
         <a:solidFill>
+          <a:srgbClr val="10243A"/>
+        </a:solidFill>
+        <a:effectLst/>
+      </p:bgPr>
+    </p:bg>
+    <p:spTree>
+      <p:nvGrpSpPr>
+        <p:cNvPr id="1" name=""/>
+        <p:cNvGrpSpPr/>
+        <p:nvPr/>
+      </p:nvGrpSpPr>
+      <p:grpSpPr/>
+      <p:pic>
+        <p:nvPicPr>
+          <p:cNvPr id="2" name="Picture 1" descr="r_ext.jpg"/>
+          <p:cNvPicPr>
+            <a:picLocks noChangeAspect="1"/>
+          </p:cNvPicPr>
+          <p:nvPr/>
+        </p:nvPicPr>
+        <p:blipFill>
+          <a:blip r:embed="rId3"/>
+          <a:srcRect l="17750" r="17750"/>
+          <a:stretch>
+            <a:fillRect/>
+          </a:stretch>
+        </p:blipFill>
+        <p:spPr>
+          <a:xfrm>
+            <a:off x="812800" y="1143000"/>
+            <a:ext cx="5461000" cy="4572000"/>
+          </a:xfrm>
+          <a:prstGeom prst="rect">
+            <a:avLst/>
+          </a:prstGeom>
+        </p:spPr>
+      </p:pic>
+      <p:sp>
+        <p:nvSpPr>
+          <p:cNvPr id="3" name="TextBox 2"/>
+          <p:cNvSpPr txBox="1"/>
+          <p:nvPr/>
+        </p:nvSpPr>
+        <p:spPr>
+          <a:xfrm>
+            <a:off x="6731000" y="952500"/>
+            <a:ext cx="4648200" cy="1841500"/>
+          </a:xfrm>
+          <a:prstGeom prst="rect">
+            <a:avLst/>
+          </a:prstGeom>
+          <a:noFill/>
+        </p:spPr>
+        <p:txBody>
+          <a:bodyPr wrap="square" lIns="0" rIns="0" tIns="0" bIns="0" anchor="t">
+            <a:spAutoFit/>
+          </a:bodyPr>
+          <a:lstStyle/>
+          <a:p>
+            <a:pPr algn="l">
+              <a:lnSpc>
+                <a:spcPct val="95000"/>
+              </a:lnSpc>
+            </a:pPr>
+            <a:r>
+              <a:rPr sz="4200" b="1">
+                <a:solidFill>
+                  <a:srgbClr val="F7F5F0"/>
+                </a:solidFill>
+                <a:latin typeface="Arial Narrow"/>
+              </a:rPr>
+              <a:t>UNA NAVE PROTEGIDA Y CONFORTABLE</a:t>
+            </a:r>
+          </a:p>
+        </p:txBody>
+      </p:sp>
+      <p:sp>
+        <p:nvSpPr>
+          <p:cNvPr id="4" name="Oval 3"/>
+          <p:cNvSpPr/>
+          <p:nvPr/>
+        </p:nvSpPr>
+        <p:spPr>
+          <a:xfrm>
+            <a:off x="6731000" y="3009900"/>
+            <a:ext cx="355600" cy="355600"/>
+          </a:xfrm>
+          <a:prstGeom prst="ellipse">
+            <a:avLst/>
+          </a:prstGeom>
+          <a:solidFill>
+            <a:srgbClr val="E8791B"/>
+          </a:solidFill>
+          <a:ln>
+            <a:noFill/>
+          </a:ln>
+          <a:effectLst/>
+        </p:spPr>
+        <p:style>
+          <a:lnRef idx="1">
+            <a:schemeClr val="accent1"/>
+          </a:lnRef>
+          <a:fillRef idx="3">
+            <a:schemeClr val="accent1"/>
+          </a:fillRef>
+          <a:effectRef idx="2">
+            <a:schemeClr val="accent1"/>
+          </a:effectRef>
+          <a:fontRef idx="minor">
+            <a:schemeClr val="lt1"/>
+          </a:fontRef>
+        </p:style>
+        <p:txBody>
+          <a:bodyPr rtlCol="0" anchor="ctr"/>
+          <a:lstStyle/>
+          <a:p>
+            <a:pPr algn="ctr"/>
+          </a:p>
+        </p:txBody>
+      </p:sp>
+      <p:sp>
+        <p:nvSpPr>
+          <p:cNvPr id="5" name="TextBox 4"/>
+          <p:cNvSpPr txBox="1"/>
+          <p:nvPr/>
+        </p:nvSpPr>
+        <p:spPr>
+          <a:xfrm>
+            <a:off x="6731000" y="3009900"/>
+            <a:ext cx="355600" cy="355600"/>
+          </a:xfrm>
+          <a:prstGeom prst="rect">
+            <a:avLst/>
+          </a:prstGeom>
+          <a:noFill/>
+        </p:spPr>
+        <p:txBody>
+          <a:bodyPr wrap="square" lIns="0" rIns="0" tIns="0" bIns="0" anchor="ctr">
+            <a:spAutoFit/>
+          </a:bodyPr>
+          <a:lstStyle/>
+          <a:p>
+            <a:pPr algn="ctr">
+              <a:lnSpc>
+                <a:spcPct val="100000"/>
+              </a:lnSpc>
+            </a:pPr>
+            <a:r>
+              <a:rPr sz="1500" b="1">
+                <a:solidFill>
+                  <a:srgbClr val="10243A"/>
+                </a:solidFill>
+                <a:latin typeface="Segoe UI Symbol"/>
+              </a:rPr>
+              <a:t>✓</a:t>
+            </a:r>
+          </a:p>
+        </p:txBody>
+      </p:sp>
+      <p:sp>
+        <p:nvSpPr>
+          <p:cNvPr id="6" name="TextBox 5"/>
+          <p:cNvSpPr txBox="1"/>
+          <p:nvPr/>
+        </p:nvSpPr>
+        <p:spPr>
+          <a:xfrm>
+            <a:off x="7239000" y="2984500"/>
+            <a:ext cx="4140200" cy="635000"/>
+          </a:xfrm>
+          <a:prstGeom prst="rect">
+            <a:avLst/>
+          </a:prstGeom>
+          <a:noFill/>
+        </p:spPr>
+        <p:txBody>
+          <a:bodyPr wrap="square" lIns="0" rIns="0" tIns="0" bIns="0" anchor="t">
+            <a:spAutoFit/>
+          </a:bodyPr>
+          <a:lstStyle/>
+          <a:p>
+            <a:pPr algn="l">
+              <a:lnSpc>
+                <a:spcPct val="105000"/>
+              </a:lnSpc>
+            </a:pPr>
+            <a:r>
+              <a:rPr sz="1600" b="1">
+                <a:solidFill>
+                  <a:srgbClr val="F7F5F0"/>
+                </a:solidFill>
+                <a:latin typeface="Calibri"/>
+              </a:rPr>
+              <a:t>Cubierta renovada.</a:t>
+            </a:r>
+            <a:r>
+              <a:rPr sz="1600" b="0">
+                <a:solidFill>
+                  <a:srgbClr val="F7F5F0"/>
+                </a:solidFill>
+                <a:latin typeface="Calibri"/>
+              </a:rPr>
+              <a:t> Más aislamiento y menos frío en invierno.</a:t>
+            </a:r>
+          </a:p>
+        </p:txBody>
+      </p:sp>
+      <p:sp>
+        <p:nvSpPr>
+          <p:cNvPr id="7" name="Oval 6"/>
+          <p:cNvSpPr/>
+          <p:nvPr/>
+        </p:nvSpPr>
+        <p:spPr>
+          <a:xfrm>
+            <a:off x="6731000" y="3683000"/>
+            <a:ext cx="355600" cy="355600"/>
+          </a:xfrm>
+          <a:prstGeom prst="ellipse">
+            <a:avLst/>
+          </a:prstGeom>
+          <a:solidFill>
+            <a:srgbClr val="E8791B"/>
+          </a:solidFill>
+          <a:ln>
+            <a:noFill/>
+          </a:ln>
+          <a:effectLst/>
+        </p:spPr>
+        <p:style>
+          <a:lnRef idx="1">
+            <a:schemeClr val="accent1"/>
+          </a:lnRef>
+          <a:fillRef idx="3">
+            <a:schemeClr val="accent1"/>
+          </a:fillRef>
+          <a:effectRef idx="2">
+            <a:schemeClr val="accent1"/>
+          </a:effectRef>
+          <a:fontRef idx="minor">
+            <a:schemeClr val="lt1"/>
+          </a:fontRef>
+        </p:style>
+        <p:txBody>
+          <a:bodyPr rtlCol="0" anchor="ctr"/>
+          <a:lstStyle/>
+          <a:p>
+            <a:pPr algn="ctr"/>
+          </a:p>
+        </p:txBody>
+      </p:sp>
+      <p:sp>
+        <p:nvSpPr>
+          <p:cNvPr id="8" name="TextBox 7"/>
+          <p:cNvSpPr txBox="1"/>
+          <p:nvPr/>
+        </p:nvSpPr>
+        <p:spPr>
+          <a:xfrm>
+            <a:off x="6731000" y="3683000"/>
+            <a:ext cx="355600" cy="355600"/>
+          </a:xfrm>
+          <a:prstGeom prst="rect">
+            <a:avLst/>
+          </a:prstGeom>
+          <a:noFill/>
+        </p:spPr>
+        <p:txBody>
+          <a:bodyPr wrap="square" lIns="0" rIns="0" tIns="0" bIns="0" anchor="ctr">
+            <a:spAutoFit/>
+          </a:bodyPr>
+          <a:lstStyle/>
+          <a:p>
+            <a:pPr algn="ctr">
+              <a:lnSpc>
+                <a:spcPct val="100000"/>
+              </a:lnSpc>
+            </a:pPr>
+            <a:r>
+              <a:rPr sz="1500" b="1">
+                <a:solidFill>
+                  <a:srgbClr val="10243A"/>
+                </a:solidFill>
+                <a:latin typeface="Segoe UI Symbol"/>
+              </a:rPr>
+              <a:t>✓</a:t>
+            </a:r>
+          </a:p>
+        </p:txBody>
+      </p:sp>
+      <p:sp>
+        <p:nvSpPr>
+          <p:cNvPr id="9" name="TextBox 8"/>
+          <p:cNvSpPr txBox="1"/>
+          <p:nvPr/>
+        </p:nvSpPr>
+        <p:spPr>
+          <a:xfrm>
+            <a:off x="7239000" y="3657600"/>
+            <a:ext cx="4140200" cy="635000"/>
+          </a:xfrm>
+          <a:prstGeom prst="rect">
+            <a:avLst/>
+          </a:prstGeom>
+          <a:noFill/>
+        </p:spPr>
+        <p:txBody>
+          <a:bodyPr wrap="square" lIns="0" rIns="0" tIns="0" bIns="0" anchor="t">
+            <a:spAutoFit/>
+          </a:bodyPr>
+          <a:lstStyle/>
+          <a:p>
+            <a:pPr algn="l">
+              <a:lnSpc>
+                <a:spcPct val="105000"/>
+              </a:lnSpc>
+            </a:pPr>
+            <a:r>
+              <a:rPr sz="1600" b="1">
+                <a:solidFill>
+                  <a:srgbClr val="F7F5F0"/>
+                </a:solidFill>
+                <a:latin typeface="Calibri"/>
+              </a:rPr>
+              <a:t>Luz natural.</a:t>
+            </a:r>
+            <a:r>
+              <a:rPr sz="1600" b="0">
+                <a:solidFill>
+                  <a:srgbClr val="F7F5F0"/>
+                </a:solidFill>
+                <a:latin typeface="Calibri"/>
+              </a:rPr>
+              <a:t> Cerramiento translúcido y control del sol en la fachada oeste.</a:t>
+            </a:r>
+          </a:p>
+        </p:txBody>
+      </p:sp>
+      <p:sp>
+        <p:nvSpPr>
+          <p:cNvPr id="10" name="Oval 9"/>
+          <p:cNvSpPr/>
+          <p:nvPr/>
+        </p:nvSpPr>
+        <p:spPr>
+          <a:xfrm>
+            <a:off x="6731000" y="4356100"/>
+            <a:ext cx="355600" cy="355600"/>
+          </a:xfrm>
+          <a:prstGeom prst="ellipse">
+            <a:avLst/>
+          </a:prstGeom>
+          <a:solidFill>
+            <a:srgbClr val="E8791B"/>
+          </a:solidFill>
+          <a:ln>
+            <a:noFill/>
+          </a:ln>
+          <a:effectLst/>
+        </p:spPr>
+        <p:style>
+          <a:lnRef idx="1">
+            <a:schemeClr val="accent1"/>
+          </a:lnRef>
+          <a:fillRef idx="3">
+            <a:schemeClr val="accent1"/>
+          </a:fillRef>
+          <a:effectRef idx="2">
+            <a:schemeClr val="accent1"/>
+          </a:effectRef>
+          <a:fontRef idx="minor">
+            <a:schemeClr val="lt1"/>
+          </a:fontRef>
+        </p:style>
+        <p:txBody>
+          <a:bodyPr rtlCol="0" anchor="ctr"/>
+          <a:lstStyle/>
+          <a:p>
+            <a:pPr algn="ctr"/>
+          </a:p>
+        </p:txBody>
+      </p:sp>
+      <p:sp>
+        <p:nvSpPr>
+          <p:cNvPr id="11" name="TextBox 10"/>
+          <p:cNvSpPr txBox="1"/>
+          <p:nvPr/>
+        </p:nvSpPr>
+        <p:spPr>
+          <a:xfrm>
+            <a:off x="6731000" y="4356100"/>
+            <a:ext cx="355600" cy="355600"/>
+          </a:xfrm>
+          <a:prstGeom prst="rect">
+            <a:avLst/>
+          </a:prstGeom>
+          <a:noFill/>
+        </p:spPr>
+        <p:txBody>
+          <a:bodyPr wrap="square" lIns="0" rIns="0" tIns="0" bIns="0" anchor="ctr">
+            <a:spAutoFit/>
+          </a:bodyPr>
+          <a:lstStyle/>
+          <a:p>
+            <a:pPr algn="ctr">
+              <a:lnSpc>
+                <a:spcPct val="100000"/>
+              </a:lnSpc>
+            </a:pPr>
+            <a:r>
+              <a:rPr sz="1500" b="1">
+                <a:solidFill>
+                  <a:srgbClr val="10243A"/>
+                </a:solidFill>
+                <a:latin typeface="Segoe UI Symbol"/>
+              </a:rPr>
+              <a:t>✓</a:t>
+            </a:r>
+          </a:p>
+        </p:txBody>
+      </p:sp>
+      <p:sp>
+        <p:nvSpPr>
+          <p:cNvPr id="12" name="TextBox 11"/>
+          <p:cNvSpPr txBox="1"/>
+          <p:nvPr/>
+        </p:nvSpPr>
+        <p:spPr>
+          <a:xfrm>
+            <a:off x="7239000" y="4330700"/>
+            <a:ext cx="4140200" cy="635000"/>
+          </a:xfrm>
+          <a:prstGeom prst="rect">
+            <a:avLst/>
+          </a:prstGeom>
+          <a:noFill/>
+        </p:spPr>
+        <p:txBody>
+          <a:bodyPr wrap="square" lIns="0" rIns="0" tIns="0" bIns="0" anchor="t">
+            <a:spAutoFit/>
+          </a:bodyPr>
+          <a:lstStyle/>
+          <a:p>
+            <a:pPr algn="l">
+              <a:lnSpc>
+                <a:spcPct val="105000"/>
+              </a:lnSpc>
+            </a:pPr>
+            <a:r>
+              <a:rPr sz="1600" b="1">
+                <a:solidFill>
+                  <a:srgbClr val="F7F5F0"/>
+                </a:solidFill>
+                <a:latin typeface="Calibri"/>
+              </a:rPr>
+              <a:t>Espacio protegido.</a:t>
+            </a:r>
+            <a:r>
+              <a:rPr sz="1600" b="0">
+                <a:solidFill>
+                  <a:srgbClr val="F7F5F0"/>
+                </a:solidFill>
+                <a:latin typeface="Calibri"/>
+              </a:rPr>
+              <a:t> Sin aves, sin lluvia y sin suciedad sobre la pista.</a:t>
+            </a:r>
+          </a:p>
+        </p:txBody>
+      </p:sp>
+      <p:sp>
+        <p:nvSpPr>
+          <p:cNvPr id="13" name="Oval 12"/>
+          <p:cNvSpPr/>
+          <p:nvPr/>
+        </p:nvSpPr>
+        <p:spPr>
+          <a:xfrm>
+            <a:off x="6731000" y="5029200"/>
+            <a:ext cx="355600" cy="355600"/>
+          </a:xfrm>
+          <a:prstGeom prst="ellipse">
+            <a:avLst/>
+          </a:prstGeom>
+          <a:solidFill>
+            <a:srgbClr val="E8791B"/>
+          </a:solidFill>
+          <a:ln>
+            <a:noFill/>
+          </a:ln>
+          <a:effectLst/>
+        </p:spPr>
+        <p:style>
+          <a:lnRef idx="1">
+            <a:schemeClr val="accent1"/>
+          </a:lnRef>
+          <a:fillRef idx="3">
+            <a:schemeClr val="accent1"/>
+          </a:fillRef>
+          <a:effectRef idx="2">
+            <a:schemeClr val="accent1"/>
+          </a:effectRef>
+          <a:fontRef idx="minor">
+            <a:schemeClr val="lt1"/>
+          </a:fontRef>
+        </p:style>
+        <p:txBody>
+          <a:bodyPr rtlCol="0" anchor="ctr"/>
+          <a:lstStyle/>
+          <a:p>
+            <a:pPr algn="ctr"/>
+          </a:p>
+        </p:txBody>
+      </p:sp>
+      <p:sp>
+        <p:nvSpPr>
+          <p:cNvPr id="14" name="TextBox 13"/>
+          <p:cNvSpPr txBox="1"/>
+          <p:nvPr/>
+        </p:nvSpPr>
+        <p:spPr>
+          <a:xfrm>
+            <a:off x="6731000" y="5029200"/>
+            <a:ext cx="355600" cy="355600"/>
+          </a:xfrm>
+          <a:prstGeom prst="rect">
+            <a:avLst/>
+          </a:prstGeom>
+          <a:noFill/>
+        </p:spPr>
+        <p:txBody>
+          <a:bodyPr wrap="square" lIns="0" rIns="0" tIns="0" bIns="0" anchor="ctr">
+            <a:spAutoFit/>
+          </a:bodyPr>
+          <a:lstStyle/>
+          <a:p>
+            <a:pPr algn="ctr">
+              <a:lnSpc>
+                <a:spcPct val="100000"/>
+              </a:lnSpc>
+            </a:pPr>
+            <a:r>
+              <a:rPr sz="1500" b="1">
+                <a:solidFill>
+                  <a:srgbClr val="10243A"/>
+                </a:solidFill>
+                <a:latin typeface="Segoe UI Symbol"/>
+              </a:rPr>
+              <a:t>✓</a:t>
+            </a:r>
+          </a:p>
+        </p:txBody>
+      </p:sp>
+      <p:sp>
+        <p:nvSpPr>
+          <p:cNvPr id="15" name="TextBox 14"/>
+          <p:cNvSpPr txBox="1"/>
+          <p:nvPr/>
+        </p:nvSpPr>
+        <p:spPr>
+          <a:xfrm>
+            <a:off x="7239000" y="5003800"/>
+            <a:ext cx="4140200" cy="635000"/>
+          </a:xfrm>
+          <a:prstGeom prst="rect">
+            <a:avLst/>
+          </a:prstGeom>
+          <a:noFill/>
+        </p:spPr>
+        <p:txBody>
+          <a:bodyPr wrap="square" lIns="0" rIns="0" tIns="0" bIns="0" anchor="t">
+            <a:spAutoFit/>
+          </a:bodyPr>
+          <a:lstStyle/>
+          <a:p>
+            <a:pPr algn="l">
+              <a:lnSpc>
+                <a:spcPct val="105000"/>
+              </a:lnSpc>
+            </a:pPr>
+            <a:r>
+              <a:rPr sz="1600" b="1">
+                <a:solidFill>
+                  <a:srgbClr val="F7F5F0"/>
+                </a:solidFill>
+                <a:latin typeface="Calibri"/>
+              </a:rPr>
+              <a:t>Entorno accesible.</a:t>
+            </a:r>
+            <a:r>
+              <a:rPr sz="1600" b="0">
+                <a:solidFill>
+                  <a:srgbClr val="F7F5F0"/>
+                </a:solidFill>
+                <a:latin typeface="Calibri"/>
+              </a:rPr>
+              <a:t> Mejor recogida de agua y acceso peatonal desde el exterior.</a:t>
+            </a:r>
+          </a:p>
+        </p:txBody>
+      </p:sp>
+    </p:spTree>
+  </p:cSld>
+  <p:clrMapOvr>
+    <a:masterClrMapping/>
+  </p:clrMapOvr>
+</p:sld>
+</file>
+
+<file path=ppt/slides/slide11.xml><?xml version="1.0" encoding="utf-8"?>
+<p:sld xmlns:a="http://schemas.openxmlformats.org/drawingml/2006/main" xmlns:p="http://schemas.openxmlformats.org/presentationml/2006/main" xmlns:r="http://schemas.openxmlformats.org/officeDocument/2006/relationships">
+  <p:cSld>
+    <p:bg>
+      <p:bgPr>
+        <a:solidFill>
           <a:srgbClr val="F7F5F0"/>
         </a:solidFill>
         <a:effectLst/>
@@ -5639,7 +6324,7 @@
 </p:sld>
 </file>
 
-<file path=ppt/slides/slide11.xml><?xml version="1.0" encoding="utf-8"?>
+<file path=ppt/slides/slide12.xml><?xml version="1.0" encoding="utf-8"?>
 <p:sld xmlns:a="http://schemas.openxmlformats.org/drawingml/2006/main" xmlns:p="http://schemas.openxmlformats.org/presentationml/2006/main" xmlns:r="http://schemas.openxmlformats.org/officeDocument/2006/relationships">
   <p:cSld>
     <p:bg>
@@ -8900,7 +9585,7 @@
                 </a:solidFill>
                 <a:latin typeface="Arial Narrow"/>
               </a:rPr>
-              <a:t>60 m</a:t>
+              <a:t>90 m</a:t>
             </a:r>
           </a:p>
         </p:txBody>
@@ -8939,7 +9624,7 @@
                 </a:solidFill>
                 <a:latin typeface="Calibri"/>
               </a:rPr>
-              <a:t>de recta para trabajar la velocidad</a:t>
+              <a:t>de pista de velocidad, con zona de frenada</a:t>
             </a:r>
           </a:p>
         </p:txBody>
@@ -9710,7 +10395,7 @@
     <p:bg>
       <p:bgPr>
         <a:solidFill>
-          <a:srgbClr val="10243A"/>
+          <a:srgbClr val="F7F5F0"/>
         </a:solidFill>
         <a:effectLst/>
       </p:bgPr>
@@ -9722,9 +10407,133 @@
         <p:nvPr/>
       </p:nvGrpSpPr>
       <p:grpSpPr/>
+      <p:sp>
+        <p:nvSpPr>
+          <p:cNvPr id="2" name="TextBox 1"/>
+          <p:cNvSpPr txBox="1"/>
+          <p:nvPr/>
+        </p:nvSpPr>
+        <p:spPr>
+          <a:xfrm>
+            <a:off x="812800" y="457200"/>
+            <a:ext cx="6350000" cy="228600"/>
+          </a:xfrm>
+          <a:prstGeom prst="rect">
+            <a:avLst/>
+          </a:prstGeom>
+          <a:noFill/>
+        </p:spPr>
+        <p:txBody>
+          <a:bodyPr wrap="square" lIns="0" rIns="0" tIns="0" bIns="0" anchor="t">
+            <a:spAutoFit/>
+          </a:bodyPr>
+          <a:lstStyle/>
+          <a:p>
+            <a:pPr algn="l">
+              <a:lnSpc>
+                <a:spcPct val="100000"/>
+              </a:lnSpc>
+            </a:pPr>
+            <a:r>
+              <a:rPr sz="1400" b="1" spc="200">
+                <a:solidFill>
+                  <a:srgbClr val="B95A0C"/>
+                </a:solidFill>
+                <a:latin typeface="Calibri"/>
+              </a:rPr>
+              <a:t>LAS SUPERFICIES</a:t>
+            </a:r>
+          </a:p>
+        </p:txBody>
+      </p:sp>
+      <p:sp>
+        <p:nvSpPr>
+          <p:cNvPr id="3" name="TextBox 2"/>
+          <p:cNvSpPr txBox="1"/>
+          <p:nvPr/>
+        </p:nvSpPr>
+        <p:spPr>
+          <a:xfrm>
+            <a:off x="812800" y="711200"/>
+            <a:ext cx="10566400" cy="635000"/>
+          </a:xfrm>
+          <a:prstGeom prst="rect">
+            <a:avLst/>
+          </a:prstGeom>
+          <a:noFill/>
+        </p:spPr>
+        <p:txBody>
+          <a:bodyPr wrap="square" lIns="0" rIns="0" tIns="0" bIns="0" anchor="t">
+            <a:spAutoFit/>
+          </a:bodyPr>
+          <a:lstStyle/>
+          <a:p>
+            <a:pPr algn="l">
+              <a:lnSpc>
+                <a:spcPct val="100000"/>
+              </a:lnSpc>
+            </a:pPr>
+            <a:r>
+              <a:rPr sz="4000" b="1">
+                <a:solidFill>
+                  <a:srgbClr val="10243A"/>
+                </a:solidFill>
+                <a:latin typeface="Arial Narrow"/>
+              </a:rPr>
+              <a:t>DOS SUPERFICIES, CADA UNA PARA LO SUYO</a:t>
+            </a:r>
+          </a:p>
+        </p:txBody>
+      </p:sp>
+      <p:sp>
+        <p:nvSpPr>
+          <p:cNvPr id="4" name="Rounded Rectangle 3"/>
+          <p:cNvSpPr/>
+          <p:nvPr/>
+        </p:nvSpPr>
+        <p:spPr>
+          <a:xfrm>
+            <a:off x="812800" y="1460500"/>
+            <a:ext cx="5181600" cy="3333750"/>
+          </a:xfrm>
+          <a:prstGeom prst="roundRect">
+            <a:avLst>
+              <a:gd name="adj" fmla="val 3809"/>
+            </a:avLst>
+          </a:prstGeom>
+          <a:solidFill>
+            <a:srgbClr val="FFFFFF"/>
+          </a:solidFill>
+          <a:ln>
+            <a:noFill/>
+          </a:ln>
+          <a:effectLst/>
+        </p:spPr>
+        <p:style>
+          <a:lnRef idx="1">
+            <a:schemeClr val="accent1"/>
+          </a:lnRef>
+          <a:fillRef idx="3">
+            <a:schemeClr val="accent1"/>
+          </a:fillRef>
+          <a:effectRef idx="2">
+            <a:schemeClr val="accent1"/>
+          </a:effectRef>
+          <a:fontRef idx="minor">
+            <a:schemeClr val="lt1"/>
+          </a:fontRef>
+        </p:style>
+        <p:txBody>
+          <a:bodyPr rtlCol="0" anchor="ctr"/>
+          <a:lstStyle/>
+          <a:p>
+            <a:pPr algn="ctr"/>
+          </a:p>
+        </p:txBody>
+      </p:sp>
       <p:pic>
         <p:nvPicPr>
-          <p:cNvPr id="2" name="Picture 1" descr="r_ext.jpg"/>
+          <p:cNvPr id="5" name="Picture 4" descr="r_atl.jpg"/>
           <p:cNvPicPr>
             <a:picLocks noChangeAspect="1"/>
           </p:cNvPicPr>
@@ -9732,15 +10541,15 @@
         </p:nvPicPr>
         <p:blipFill>
           <a:blip r:embed="rId3"/>
-          <a:srcRect l="17750" r="17750"/>
+          <a:srcRect t="27306" b="27306"/>
           <a:stretch>
             <a:fillRect/>
           </a:stretch>
         </p:blipFill>
         <p:spPr>
           <a:xfrm>
-            <a:off x="812800" y="1143000"/>
-            <a:ext cx="5461000" cy="4572000"/>
+            <a:off x="812800" y="1460500"/>
+            <a:ext cx="5181600" cy="1270000"/>
           </a:xfrm>
           <a:prstGeom prst="rect">
             <a:avLst/>
@@ -9749,14 +10558,99 @@
       </p:pic>
       <p:sp>
         <p:nvSpPr>
-          <p:cNvPr id="3" name="TextBox 2"/>
+          <p:cNvPr id="6" name="Rounded Rectangle 5"/>
+          <p:cNvSpPr/>
+          <p:nvPr/>
+        </p:nvSpPr>
+        <p:spPr>
+          <a:xfrm>
+            <a:off x="1041400" y="2921000"/>
+            <a:ext cx="1270000" cy="279400"/>
+          </a:xfrm>
+          <a:prstGeom prst="roundRect">
+            <a:avLst>
+              <a:gd name="adj" fmla="val 50000"/>
+            </a:avLst>
+          </a:prstGeom>
+          <a:solidFill>
+            <a:srgbClr val="0E9347"/>
+          </a:solidFill>
+          <a:ln>
+            <a:noFill/>
+          </a:ln>
+          <a:effectLst/>
+        </p:spPr>
+        <p:style>
+          <a:lnRef idx="1">
+            <a:schemeClr val="accent1"/>
+          </a:lnRef>
+          <a:fillRef idx="3">
+            <a:schemeClr val="accent1"/>
+          </a:fillRef>
+          <a:effectRef idx="2">
+            <a:schemeClr val="accent1"/>
+          </a:effectRef>
+          <a:fontRef idx="minor">
+            <a:schemeClr val="lt1"/>
+          </a:fontRef>
+        </p:style>
+        <p:txBody>
+          <a:bodyPr rtlCol="0" anchor="ctr"/>
+          <a:lstStyle/>
+          <a:p>
+            <a:pPr algn="ctr"/>
+          </a:p>
+        </p:txBody>
+      </p:sp>
+      <p:sp>
+        <p:nvSpPr>
+          <p:cNvPr id="7" name="TextBox 6"/>
           <p:cNvSpPr txBox="1"/>
           <p:nvPr/>
         </p:nvSpPr>
         <p:spPr>
           <a:xfrm>
-            <a:off x="6731000" y="952500"/>
-            <a:ext cx="4648200" cy="1841500"/>
+            <a:off x="1041400" y="2921000"/>
+            <a:ext cx="1270000" cy="279400"/>
+          </a:xfrm>
+          <a:prstGeom prst="rect">
+            <a:avLst/>
+          </a:prstGeom>
+          <a:noFill/>
+        </p:spPr>
+        <p:txBody>
+          <a:bodyPr wrap="square" lIns="0" rIns="0" tIns="0" bIns="0" anchor="ctr">
+            <a:spAutoFit/>
+          </a:bodyPr>
+          <a:lstStyle/>
+          <a:p>
+            <a:pPr algn="ctr">
+              <a:lnSpc>
+                <a:spcPct val="100000"/>
+              </a:lnSpc>
+            </a:pPr>
+            <a:r>
+              <a:rPr sz="1300" b="1" spc="150">
+                <a:solidFill>
+                  <a:srgbClr val="F7F5F0"/>
+                </a:solidFill>
+                <a:latin typeface="Calibri"/>
+              </a:rPr>
+              <a:t>ATLETISMO</a:t>
+            </a:r>
+          </a:p>
+        </p:txBody>
+      </p:sp>
+      <p:sp>
+        <p:nvSpPr>
+          <p:cNvPr id="8" name="TextBox 7"/>
+          <p:cNvSpPr txBox="1"/>
+          <p:nvPr/>
+        </p:nvSpPr>
+        <p:spPr>
+          <a:xfrm>
+            <a:off x="1041400" y="3289300"/>
+            <a:ext cx="4724400" cy="393700"/>
           </a:xfrm>
           <a:prstGeom prst="rect">
             <a:avLst/>
@@ -9771,34 +10665,224 @@
           <a:p>
             <a:pPr algn="l">
               <a:lnSpc>
-                <a:spcPct val="95000"/>
+                <a:spcPct val="100000"/>
               </a:lnSpc>
             </a:pPr>
             <a:r>
-              <a:rPr sz="4200" b="1">
-                <a:solidFill>
-                  <a:srgbClr val="F7F5F0"/>
+              <a:rPr sz="2500" b="1">
+                <a:solidFill>
+                  <a:srgbClr val="10243A"/>
                 </a:solidFill>
                 <a:latin typeface="Arial Narrow"/>
               </a:rPr>
-              <a:t>UNA NAVE PROTEGIDA Y CONFORTABLE</a:t>
-            </a:r>
-          </a:p>
-        </p:txBody>
-      </p:sp>
-      <p:sp>
-        <p:nvSpPr>
-          <p:cNvPr id="4" name="Oval 3"/>
+              <a:t>TARTÁN SINTÉTICO</a:t>
+            </a:r>
+          </a:p>
+        </p:txBody>
+      </p:sp>
+      <p:sp>
+        <p:nvSpPr>
+          <p:cNvPr id="9" name="TextBox 8"/>
+          <p:cNvSpPr txBox="1"/>
+          <p:nvPr/>
+        </p:nvSpPr>
+        <p:spPr>
+          <a:xfrm>
+            <a:off x="1041400" y="3759200"/>
+            <a:ext cx="4724400" cy="279400"/>
+          </a:xfrm>
+          <a:prstGeom prst="rect">
+            <a:avLst/>
+          </a:prstGeom>
+          <a:noFill/>
+        </p:spPr>
+        <p:txBody>
+          <a:bodyPr wrap="square" lIns="0" rIns="0" tIns="0" bIns="0" anchor="t">
+            <a:spAutoFit/>
+          </a:bodyPr>
+          <a:lstStyle/>
+          <a:p>
+            <a:pPr algn="l">
+              <a:lnSpc>
+                <a:spcPct val="100000"/>
+              </a:lnSpc>
+            </a:pPr>
+            <a:r>
+              <a:rPr sz="1500" b="0">
+                <a:solidFill>
+                  <a:srgbClr val="3E4C5E"/>
+                </a:solidFill>
+                <a:latin typeface="Calibri"/>
+              </a:rPr>
+              <a:t>•  Poroso y aplicado in situ</a:t>
+            </a:r>
+          </a:p>
+        </p:txBody>
+      </p:sp>
+      <p:sp>
+        <p:nvSpPr>
+          <p:cNvPr id="10" name="TextBox 9"/>
+          <p:cNvSpPr txBox="1"/>
+          <p:nvPr/>
+        </p:nvSpPr>
+        <p:spPr>
+          <a:xfrm>
+            <a:off x="1041400" y="4076700"/>
+            <a:ext cx="4724400" cy="279400"/>
+          </a:xfrm>
+          <a:prstGeom prst="rect">
+            <a:avLst/>
+          </a:prstGeom>
+          <a:noFill/>
+        </p:spPr>
+        <p:txBody>
+          <a:bodyPr wrap="square" lIns="0" rIns="0" tIns="0" bIns="0" anchor="t">
+            <a:spAutoFit/>
+          </a:bodyPr>
+          <a:lstStyle/>
+          <a:p>
+            <a:pPr algn="l">
+              <a:lnSpc>
+                <a:spcPct val="100000"/>
+              </a:lnSpc>
+            </a:pPr>
+            <a:r>
+              <a:rPr sz="1500" b="0">
+                <a:solidFill>
+                  <a:srgbClr val="3E4C5E"/>
+                </a:solidFill>
+                <a:latin typeface="Calibri"/>
+              </a:rPr>
+              <a:t>•  Acabado en azul con resina roja</a:t>
+            </a:r>
+          </a:p>
+        </p:txBody>
+      </p:sp>
+      <p:sp>
+        <p:nvSpPr>
+          <p:cNvPr id="11" name="TextBox 10"/>
+          <p:cNvSpPr txBox="1"/>
+          <p:nvPr/>
+        </p:nvSpPr>
+        <p:spPr>
+          <a:xfrm>
+            <a:off x="1041400" y="4394200"/>
+            <a:ext cx="4724400" cy="279400"/>
+          </a:xfrm>
+          <a:prstGeom prst="rect">
+            <a:avLst/>
+          </a:prstGeom>
+          <a:noFill/>
+        </p:spPr>
+        <p:txBody>
+          <a:bodyPr wrap="square" lIns="0" rIns="0" tIns="0" bIns="0" anchor="t">
+            <a:spAutoFit/>
+          </a:bodyPr>
+          <a:lstStyle/>
+          <a:p>
+            <a:pPr algn="l">
+              <a:lnSpc>
+                <a:spcPct val="100000"/>
+              </a:lnSpc>
+            </a:pPr>
+            <a:r>
+              <a:rPr sz="1500" b="0">
+                <a:solidFill>
+                  <a:srgbClr val="3E4C5E"/>
+                </a:solidFill>
+                <a:latin typeface="Calibri"/>
+              </a:rPr>
+              <a:t>•  Homologado por la RFEA</a:t>
+            </a:r>
+          </a:p>
+        </p:txBody>
+      </p:sp>
+      <p:sp>
+        <p:nvSpPr>
+          <p:cNvPr id="12" name="Rounded Rectangle 11"/>
           <p:cNvSpPr/>
           <p:nvPr/>
         </p:nvSpPr>
         <p:spPr>
           <a:xfrm>
-            <a:off x="6731000" y="3009900"/>
-            <a:ext cx="355600" cy="355600"/>
-          </a:xfrm>
-          <a:prstGeom prst="ellipse">
-            <a:avLst/>
+            <a:off x="6197600" y="1460500"/>
+            <a:ext cx="5181600" cy="3333750"/>
+          </a:xfrm>
+          <a:prstGeom prst="roundRect">
+            <a:avLst>
+              <a:gd name="adj" fmla="val 3809"/>
+            </a:avLst>
+          </a:prstGeom>
+          <a:solidFill>
+            <a:srgbClr val="FFFFFF"/>
+          </a:solidFill>
+          <a:ln>
+            <a:noFill/>
+          </a:ln>
+          <a:effectLst/>
+        </p:spPr>
+        <p:style>
+          <a:lnRef idx="1">
+            <a:schemeClr val="accent1"/>
+          </a:lnRef>
+          <a:fillRef idx="3">
+            <a:schemeClr val="accent1"/>
+          </a:fillRef>
+          <a:effectRef idx="2">
+            <a:schemeClr val="accent1"/>
+          </a:effectRef>
+          <a:fontRef idx="minor">
+            <a:schemeClr val="lt1"/>
+          </a:fontRef>
+        </p:style>
+        <p:txBody>
+          <a:bodyPr rtlCol="0" anchor="ctr"/>
+          <a:lstStyle/>
+          <a:p>
+            <a:pPr algn="ctr"/>
+          </a:p>
+        </p:txBody>
+      </p:sp>
+      <p:pic>
+        <p:nvPicPr>
+          <p:cNvPr id="13" name="Picture 12" descr="r_cancha.jpg"/>
+          <p:cNvPicPr>
+            <a:picLocks noChangeAspect="1"/>
+          </p:cNvPicPr>
+          <p:nvPr/>
+        </p:nvPicPr>
+        <p:blipFill>
+          <a:blip r:embed="rId4"/>
+          <a:srcRect t="27306" b="27306"/>
+          <a:stretch>
+            <a:fillRect/>
+          </a:stretch>
+        </p:blipFill>
+        <p:spPr>
+          <a:xfrm>
+            <a:off x="6197600" y="1460500"/>
+            <a:ext cx="5181600" cy="1270000"/>
+          </a:xfrm>
+          <a:prstGeom prst="rect">
+            <a:avLst/>
+          </a:prstGeom>
+        </p:spPr>
+      </p:pic>
+      <p:sp>
+        <p:nvSpPr>
+          <p:cNvPr id="14" name="Rounded Rectangle 13"/>
+          <p:cNvSpPr/>
+          <p:nvPr/>
+        </p:nvSpPr>
+        <p:spPr>
+          <a:xfrm>
+            <a:off x="6426200" y="2921000"/>
+            <a:ext cx="2667000" cy="279400"/>
+          </a:xfrm>
+          <a:prstGeom prst="roundRect">
+            <a:avLst>
+              <a:gd name="adj" fmla="val 50000"/>
+            </a:avLst>
           </a:prstGeom>
           <a:solidFill>
             <a:srgbClr val="E8791B"/>
@@ -9832,14 +10916,14 @@
       </p:sp>
       <p:sp>
         <p:nvSpPr>
-          <p:cNvPr id="5" name="TextBox 4"/>
+          <p:cNvPr id="15" name="TextBox 14"/>
           <p:cNvSpPr txBox="1"/>
           <p:nvPr/>
         </p:nvSpPr>
         <p:spPr>
           <a:xfrm>
-            <a:off x="6731000" y="3009900"/>
-            <a:ext cx="355600" cy="355600"/>
+            <a:off x="6426200" y="2921000"/>
+            <a:ext cx="2667000" cy="279400"/>
           </a:xfrm>
           <a:prstGeom prst="rect">
             <a:avLst/>
@@ -9858,27 +10942,27 @@
               </a:lnSpc>
             </a:pPr>
             <a:r>
-              <a:rPr sz="1500" b="1">
+              <a:rPr sz="1300" b="1" spc="150">
                 <a:solidFill>
                   <a:srgbClr val="10243A"/>
                 </a:solidFill>
-                <a:latin typeface="Segoe UI Symbol"/>
+                <a:latin typeface="Calibri"/>
               </a:rPr>
-              <a:t>✓</a:t>
-            </a:r>
-          </a:p>
-        </p:txBody>
-      </p:sp>
-      <p:sp>
-        <p:nvSpPr>
-          <p:cNvPr id="6" name="TextBox 5"/>
+              <a:t>PISTAS MULTIDEPORTE</a:t>
+            </a:r>
+          </a:p>
+        </p:txBody>
+      </p:sp>
+      <p:sp>
+        <p:nvSpPr>
+          <p:cNvPr id="16" name="TextBox 15"/>
           <p:cNvSpPr txBox="1"/>
           <p:nvPr/>
         </p:nvSpPr>
         <p:spPr>
           <a:xfrm>
-            <a:off x="7239000" y="2984500"/>
-            <a:ext cx="4140200" cy="635000"/>
+            <a:off x="6426200" y="3289300"/>
+            <a:ext cx="4724400" cy="393700"/>
           </a:xfrm>
           <a:prstGeom prst="rect">
             <a:avLst/>
@@ -9893,46 +10977,195 @@
           <a:p>
             <a:pPr algn="l">
               <a:lnSpc>
-                <a:spcPct val="105000"/>
+                <a:spcPct val="100000"/>
               </a:lnSpc>
             </a:pPr>
             <a:r>
-              <a:rPr sz="1600" b="1">
-                <a:solidFill>
-                  <a:srgbClr val="F7F5F0"/>
+              <a:rPr sz="2500" b="1">
+                <a:solidFill>
+                  <a:srgbClr val="10243A"/>
+                </a:solidFill>
+                <a:latin typeface="Arial Narrow"/>
+              </a:rPr>
+              <a:t>PAVIMENTO DE PVC O RESINAS</a:t>
+            </a:r>
+          </a:p>
+        </p:txBody>
+      </p:sp>
+      <p:sp>
+        <p:nvSpPr>
+          <p:cNvPr id="17" name="TextBox 16"/>
+          <p:cNvSpPr txBox="1"/>
+          <p:nvPr/>
+        </p:nvSpPr>
+        <p:spPr>
+          <a:xfrm>
+            <a:off x="6426200" y="3759200"/>
+            <a:ext cx="4724400" cy="279400"/>
+          </a:xfrm>
+          <a:prstGeom prst="rect">
+            <a:avLst/>
+          </a:prstGeom>
+          <a:noFill/>
+        </p:spPr>
+        <p:txBody>
+          <a:bodyPr wrap="square" lIns="0" rIns="0" tIns="0" bIns="0" anchor="t">
+            <a:spAutoFit/>
+          </a:bodyPr>
+          <a:lstStyle/>
+          <a:p>
+            <a:pPr algn="l">
+              <a:lnSpc>
+                <a:spcPct val="100000"/>
+              </a:lnSpc>
+            </a:pPr>
+            <a:r>
+              <a:rPr sz="1500" b="0">
+                <a:solidFill>
+                  <a:srgbClr val="3E4C5E"/>
                 </a:solidFill>
                 <a:latin typeface="Calibri"/>
               </a:rPr>
-              <a:t>Cubierta renovada.</a:t>
-            </a:r>
-            <a:r>
-              <a:rPr sz="1600" b="0">
-                <a:solidFill>
-                  <a:srgbClr val="F7F5F0"/>
+              <a:t>•  Como en los pabellones cubiertos</a:t>
+            </a:r>
+          </a:p>
+        </p:txBody>
+      </p:sp>
+      <p:sp>
+        <p:nvSpPr>
+          <p:cNvPr id="18" name="TextBox 17"/>
+          <p:cNvSpPr txBox="1"/>
+          <p:nvPr/>
+        </p:nvSpPr>
+        <p:spPr>
+          <a:xfrm>
+            <a:off x="6426200" y="4076700"/>
+            <a:ext cx="4724400" cy="279400"/>
+          </a:xfrm>
+          <a:prstGeom prst="rect">
+            <a:avLst/>
+          </a:prstGeom>
+          <a:noFill/>
+        </p:spPr>
+        <p:txBody>
+          <a:bodyPr wrap="square" lIns="0" rIns="0" tIns="0" bIns="0" anchor="t">
+            <a:spAutoFit/>
+          </a:bodyPr>
+          <a:lstStyle/>
+          <a:p>
+            <a:pPr algn="l">
+              <a:lnSpc>
+                <a:spcPct val="100000"/>
+              </a:lnSpc>
+            </a:pPr>
+            <a:r>
+              <a:rPr sz="1500" b="0">
+                <a:solidFill>
+                  <a:srgbClr val="3E4C5E"/>
                 </a:solidFill>
                 <a:latin typeface="Calibri"/>
               </a:rPr>
-              <a:t> Más aislamiento y menos frío en invierno.</a:t>
-            </a:r>
-          </a:p>
-        </p:txBody>
-      </p:sp>
-      <p:sp>
-        <p:nvSpPr>
-          <p:cNvPr id="7" name="Oval 6"/>
+              <a:t>•  Para fútbol sala, baloncesto, voleibol y tenis</a:t>
+            </a:r>
+          </a:p>
+        </p:txBody>
+      </p:sp>
+      <p:sp>
+        <p:nvSpPr>
+          <p:cNvPr id="19" name="TextBox 18"/>
+          <p:cNvSpPr txBox="1"/>
+          <p:nvPr/>
+        </p:nvSpPr>
+        <p:spPr>
+          <a:xfrm>
+            <a:off x="6426200" y="4394200"/>
+            <a:ext cx="4724400" cy="279400"/>
+          </a:xfrm>
+          <a:prstGeom prst="rect">
+            <a:avLst/>
+          </a:prstGeom>
+          <a:noFill/>
+        </p:spPr>
+        <p:txBody>
+          <a:bodyPr wrap="square" lIns="0" rIns="0" tIns="0" bIns="0" anchor="t">
+            <a:spAutoFit/>
+          </a:bodyPr>
+          <a:lstStyle/>
+          <a:p>
+            <a:pPr algn="l">
+              <a:lnSpc>
+                <a:spcPct val="100000"/>
+              </a:lnSpc>
+            </a:pPr>
+            <a:r>
+              <a:rPr sz="1500" b="0">
+                <a:solidFill>
+                  <a:srgbClr val="3E4C5E"/>
+                </a:solidFill>
+                <a:latin typeface="Calibri"/>
+              </a:rPr>
+              <a:t>•  Líneas de cada deporte en la misma pista</a:t>
+            </a:r>
+          </a:p>
+        </p:txBody>
+      </p:sp>
+      <p:sp>
+        <p:nvSpPr>
+          <p:cNvPr id="20" name="TextBox 19"/>
+          <p:cNvSpPr txBox="1"/>
+          <p:nvPr/>
+        </p:nvSpPr>
+        <p:spPr>
+          <a:xfrm>
+            <a:off x="812800" y="4972050"/>
+            <a:ext cx="10566400" cy="317500"/>
+          </a:xfrm>
+          <a:prstGeom prst="rect">
+            <a:avLst/>
+          </a:prstGeom>
+          <a:noFill/>
+        </p:spPr>
+        <p:txBody>
+          <a:bodyPr wrap="square" lIns="0" rIns="0" tIns="0" bIns="0" anchor="t">
+            <a:spAutoFit/>
+          </a:bodyPr>
+          <a:lstStyle/>
+          <a:p>
+            <a:pPr algn="l">
+              <a:lnSpc>
+                <a:spcPct val="100000"/>
+              </a:lnSpc>
+            </a:pPr>
+            <a:r>
+              <a:rPr sz="2000" b="1" spc="100">
+                <a:solidFill>
+                  <a:srgbClr val="10243A"/>
+                </a:solidFill>
+                <a:latin typeface="Arial Narrow"/>
+              </a:rPr>
+              <a:t>SE PUEDE EJECUTAR POR FASES</a:t>
+            </a:r>
+          </a:p>
+        </p:txBody>
+      </p:sp>
+      <p:sp>
+        <p:nvSpPr>
+          <p:cNvPr id="21" name="Rounded Rectangle 20"/>
           <p:cNvSpPr/>
           <p:nvPr/>
         </p:nvSpPr>
         <p:spPr>
           <a:xfrm>
-            <a:off x="6731000" y="3683000"/>
-            <a:ext cx="355600" cy="355600"/>
-          </a:xfrm>
-          <a:prstGeom prst="ellipse">
-            <a:avLst/>
+            <a:off x="812800" y="5372100"/>
+            <a:ext cx="3282950" cy="419100"/>
+          </a:xfrm>
+          <a:prstGeom prst="roundRect">
+            <a:avLst>
+              <a:gd name="adj" fmla="val 21212"/>
+            </a:avLst>
           </a:prstGeom>
           <a:solidFill>
-            <a:srgbClr val="E8791B"/>
+            <a:srgbClr val="10243A"/>
           </a:solidFill>
           <a:ln>
             <a:noFill/>
@@ -9963,14 +11196,14 @@
       </p:sp>
       <p:sp>
         <p:nvSpPr>
-          <p:cNvPr id="8" name="TextBox 7"/>
+          <p:cNvPr id="22" name="TextBox 21"/>
           <p:cNvSpPr txBox="1"/>
           <p:nvPr/>
         </p:nvSpPr>
         <p:spPr>
           <a:xfrm>
-            <a:off x="6731000" y="3683000"/>
-            <a:ext cx="355600" cy="355600"/>
+            <a:off x="812800" y="5372100"/>
+            <a:ext cx="3282950" cy="419100"/>
           </a:xfrm>
           <a:prstGeom prst="rect">
             <a:avLst/>
@@ -9989,27 +11222,27 @@
               </a:lnSpc>
             </a:pPr>
             <a:r>
-              <a:rPr sz="1500" b="1">
-                <a:solidFill>
-                  <a:srgbClr val="10243A"/>
-                </a:solidFill>
-                <a:latin typeface="Segoe UI Symbol"/>
+              <a:rPr sz="1400" b="1">
+                <a:solidFill>
+                  <a:srgbClr val="F7F5F0"/>
+                </a:solidFill>
+                <a:latin typeface="Calibri"/>
               </a:rPr>
-              <a:t>✓</a:t>
-            </a:r>
-          </a:p>
-        </p:txBody>
-      </p:sp>
-      <p:sp>
-        <p:nvSpPr>
-          <p:cNvPr id="9" name="TextBox 8"/>
+              <a:t>1 · Módulo de atletismo</a:t>
+            </a:r>
+          </a:p>
+        </p:txBody>
+      </p:sp>
+      <p:sp>
+        <p:nvSpPr>
+          <p:cNvPr id="23" name="TextBox 22"/>
           <p:cNvSpPr txBox="1"/>
           <p:nvPr/>
         </p:nvSpPr>
         <p:spPr>
           <a:xfrm>
-            <a:off x="7239000" y="3657600"/>
-            <a:ext cx="4140200" cy="635000"/>
+            <a:off x="4095750" y="5372100"/>
+            <a:ext cx="355600" cy="419100"/>
           </a:xfrm>
           <a:prstGeom prst="rect">
             <a:avLst/>
@@ -10017,53 +11250,46 @@
           <a:noFill/>
         </p:spPr>
         <p:txBody>
-          <a:bodyPr wrap="square" lIns="0" rIns="0" tIns="0" bIns="0" anchor="t">
+          <a:bodyPr wrap="square" lIns="0" rIns="0" tIns="0" bIns="0" anchor="ctr">
             <a:spAutoFit/>
           </a:bodyPr>
           <a:lstStyle/>
           <a:p>
-            <a:pPr algn="l">
+            <a:pPr algn="ctr">
               <a:lnSpc>
-                <a:spcPct val="105000"/>
+                <a:spcPct val="100000"/>
               </a:lnSpc>
             </a:pPr>
             <a:r>
-              <a:rPr sz="1600" b="1">
-                <a:solidFill>
-                  <a:srgbClr val="F7F5F0"/>
+              <a:rPr sz="2000" b="1">
+                <a:solidFill>
+                  <a:srgbClr val="E8791B"/>
                 </a:solidFill>
                 <a:latin typeface="Calibri"/>
               </a:rPr>
-              <a:t>Luz natural.</a:t>
-            </a:r>
-            <a:r>
-              <a:rPr sz="1600" b="0">
-                <a:solidFill>
-                  <a:srgbClr val="F7F5F0"/>
-                </a:solidFill>
-                <a:latin typeface="Calibri"/>
-              </a:rPr>
-              <a:t> Cerramiento translúcido y control del sol en la fachada oeste.</a:t>
-            </a:r>
-          </a:p>
-        </p:txBody>
-      </p:sp>
-      <p:sp>
-        <p:nvSpPr>
-          <p:cNvPr id="10" name="Oval 9"/>
+              <a:t>→</a:t>
+            </a:r>
+          </a:p>
+        </p:txBody>
+      </p:sp>
+      <p:sp>
+        <p:nvSpPr>
+          <p:cNvPr id="24" name="Rounded Rectangle 23"/>
           <p:cNvSpPr/>
           <p:nvPr/>
         </p:nvSpPr>
         <p:spPr>
           <a:xfrm>
-            <a:off x="6731000" y="4356100"/>
-            <a:ext cx="355600" cy="355600"/>
-          </a:xfrm>
-          <a:prstGeom prst="ellipse">
-            <a:avLst/>
+            <a:off x="4451350" y="5372100"/>
+            <a:ext cx="3282950" cy="419100"/>
+          </a:xfrm>
+          <a:prstGeom prst="roundRect">
+            <a:avLst>
+              <a:gd name="adj" fmla="val 21212"/>
+            </a:avLst>
           </a:prstGeom>
           <a:solidFill>
-            <a:srgbClr val="E8791B"/>
+            <a:srgbClr val="10243A"/>
           </a:solidFill>
           <a:ln>
             <a:noFill/>
@@ -10094,14 +11320,14 @@
       </p:sp>
       <p:sp>
         <p:nvSpPr>
-          <p:cNvPr id="11" name="TextBox 10"/>
+          <p:cNvPr id="25" name="TextBox 24"/>
           <p:cNvSpPr txBox="1"/>
           <p:nvPr/>
         </p:nvSpPr>
         <p:spPr>
           <a:xfrm>
-            <a:off x="6731000" y="4356100"/>
-            <a:ext cx="355600" cy="355600"/>
+            <a:off x="4451350" y="5372100"/>
+            <a:ext cx="3282950" cy="419100"/>
           </a:xfrm>
           <a:prstGeom prst="rect">
             <a:avLst/>
@@ -10120,27 +11346,27 @@
               </a:lnSpc>
             </a:pPr>
             <a:r>
-              <a:rPr sz="1500" b="1">
-                <a:solidFill>
-                  <a:srgbClr val="10243A"/>
-                </a:solidFill>
-                <a:latin typeface="Segoe UI Symbol"/>
+              <a:rPr sz="1400" b="1">
+                <a:solidFill>
+                  <a:srgbClr val="F7F5F0"/>
+                </a:solidFill>
+                <a:latin typeface="Calibri"/>
               </a:rPr>
-              <a:t>✓</a:t>
-            </a:r>
-          </a:p>
-        </p:txBody>
-      </p:sp>
-      <p:sp>
-        <p:nvSpPr>
-          <p:cNvPr id="12" name="TextBox 11"/>
+              <a:t>2 · Pistas multideporte</a:t>
+            </a:r>
+          </a:p>
+        </p:txBody>
+      </p:sp>
+      <p:sp>
+        <p:nvSpPr>
+          <p:cNvPr id="26" name="TextBox 25"/>
           <p:cNvSpPr txBox="1"/>
           <p:nvPr/>
         </p:nvSpPr>
         <p:spPr>
           <a:xfrm>
-            <a:off x="7239000" y="4330700"/>
-            <a:ext cx="4140200" cy="635000"/>
+            <a:off x="7734300" y="5372100"/>
+            <a:ext cx="355600" cy="419100"/>
           </a:xfrm>
           <a:prstGeom prst="rect">
             <a:avLst/>
@@ -10148,53 +11374,46 @@
           <a:noFill/>
         </p:spPr>
         <p:txBody>
-          <a:bodyPr wrap="square" lIns="0" rIns="0" tIns="0" bIns="0" anchor="t">
+          <a:bodyPr wrap="square" lIns="0" rIns="0" tIns="0" bIns="0" anchor="ctr">
             <a:spAutoFit/>
           </a:bodyPr>
           <a:lstStyle/>
           <a:p>
-            <a:pPr algn="l">
+            <a:pPr algn="ctr">
               <a:lnSpc>
-                <a:spcPct val="105000"/>
+                <a:spcPct val="100000"/>
               </a:lnSpc>
             </a:pPr>
             <a:r>
-              <a:rPr sz="1600" b="1">
-                <a:solidFill>
-                  <a:srgbClr val="F7F5F0"/>
+              <a:rPr sz="2000" b="1">
+                <a:solidFill>
+                  <a:srgbClr val="E8791B"/>
                 </a:solidFill>
                 <a:latin typeface="Calibri"/>
               </a:rPr>
-              <a:t>Espacio protegido.</a:t>
-            </a:r>
-            <a:r>
-              <a:rPr sz="1600" b="0">
-                <a:solidFill>
-                  <a:srgbClr val="F7F5F0"/>
-                </a:solidFill>
-                <a:latin typeface="Calibri"/>
-              </a:rPr>
-              <a:t> Sin aves, sin lluvia y sin suciedad sobre la pista.</a:t>
-            </a:r>
-          </a:p>
-        </p:txBody>
-      </p:sp>
-      <p:sp>
-        <p:nvSpPr>
-          <p:cNvPr id="13" name="Oval 12"/>
+              <a:t>→</a:t>
+            </a:r>
+          </a:p>
+        </p:txBody>
+      </p:sp>
+      <p:sp>
+        <p:nvSpPr>
+          <p:cNvPr id="27" name="Rounded Rectangle 26"/>
           <p:cNvSpPr/>
           <p:nvPr/>
         </p:nvSpPr>
         <p:spPr>
           <a:xfrm>
-            <a:off x="6731000" y="5029200"/>
-            <a:ext cx="355600" cy="355600"/>
-          </a:xfrm>
-          <a:prstGeom prst="ellipse">
-            <a:avLst/>
+            <a:off x="8089900" y="5372100"/>
+            <a:ext cx="3282950" cy="419100"/>
+          </a:xfrm>
+          <a:prstGeom prst="roundRect">
+            <a:avLst>
+              <a:gd name="adj" fmla="val 21212"/>
+            </a:avLst>
           </a:prstGeom>
           <a:solidFill>
-            <a:srgbClr val="E8791B"/>
+            <a:srgbClr val="10243A"/>
           </a:solidFill>
           <a:ln>
             <a:noFill/>
@@ -10225,14 +11444,14 @@
       </p:sp>
       <p:sp>
         <p:nvSpPr>
-          <p:cNvPr id="14" name="TextBox 13"/>
+          <p:cNvPr id="28" name="TextBox 27"/>
           <p:cNvSpPr txBox="1"/>
           <p:nvPr/>
         </p:nvSpPr>
         <p:spPr>
           <a:xfrm>
-            <a:off x="6731000" y="5029200"/>
-            <a:ext cx="355600" cy="355600"/>
+            <a:off x="8089900" y="5372100"/>
+            <a:ext cx="3282950" cy="419100"/>
           </a:xfrm>
           <a:prstGeom prst="rect">
             <a:avLst/>
@@ -10251,27 +11470,27 @@
               </a:lnSpc>
             </a:pPr>
             <a:r>
-              <a:rPr sz="1500" b="1">
-                <a:solidFill>
-                  <a:srgbClr val="10243A"/>
-                </a:solidFill>
-                <a:latin typeface="Segoe UI Symbol"/>
+              <a:rPr sz="1400" b="1">
+                <a:solidFill>
+                  <a:srgbClr val="F7F5F0"/>
+                </a:solidFill>
+                <a:latin typeface="Calibri"/>
               </a:rPr>
-              <a:t>✓</a:t>
-            </a:r>
-          </a:p>
-        </p:txBody>
-      </p:sp>
-      <p:sp>
-        <p:nvSpPr>
-          <p:cNvPr id="15" name="TextBox 14"/>
+              <a:t>3 · Cubierta y cerramiento</a:t>
+            </a:r>
+          </a:p>
+        </p:txBody>
+      </p:sp>
+      <p:sp>
+        <p:nvSpPr>
+          <p:cNvPr id="29" name="TextBox 28"/>
           <p:cNvSpPr txBox="1"/>
           <p:nvPr/>
         </p:nvSpPr>
         <p:spPr>
           <a:xfrm>
-            <a:off x="7239000" y="5003800"/>
-            <a:ext cx="4140200" cy="635000"/>
+            <a:off x="812800" y="5905500"/>
+            <a:ext cx="10566400" cy="254000"/>
           </a:xfrm>
           <a:prstGeom prst="rect">
             <a:avLst/>
@@ -10286,26 +11505,17 @@
           <a:p>
             <a:pPr algn="l">
               <a:lnSpc>
-                <a:spcPct val="105000"/>
+                <a:spcPct val="100000"/>
               </a:lnSpc>
             </a:pPr>
             <a:r>
-              <a:rPr sz="1600" b="1">
-                <a:solidFill>
-                  <a:srgbClr val="F7F5F0"/>
+              <a:rPr sz="1300" b="0">
+                <a:solidFill>
+                  <a:srgbClr val="3E4C5E"/>
                 </a:solidFill>
                 <a:latin typeface="Calibri"/>
               </a:rPr>
-              <a:t>Entorno accesible.</a:t>
-            </a:r>
-            <a:r>
-              <a:rPr sz="1600" b="0">
-                <a:solidFill>
-                  <a:srgbClr val="F7F5F0"/>
-                </a:solidFill>
-                <a:latin typeface="Calibri"/>
-              </a:rPr>
-              <a:t> Mejor recogida de agua y acceso peatonal desde el exterior.</a:t>
+              <a:t>Cada superficie es independiente, así que el orden se puede adaptar. Estimación del proyecto: unos 6 meses en total.</a:t>
             </a:r>
           </a:p>
         </p:txBody>

</xml_diff>

<commit_message>
Diapositiva de superficies con primeros planos diferenciados
- Tartán azul (atletismo) y pavimento verde (pistas) en primer plano
- Franja de color por tarjeta y mayor altura de imagen
- Nuevas vistas tartan y pvc en el visor 3D
- PowerPoint y PDF (completo y ligero) actualizados

Co-Authored-By: Claude Sonnet 5.5 <noreply@anthropic.com>
</commit_message>
<xml_diff>
--- a/exportacion/Presentacion_Mejora_Pistas_Multideporte.pptx
+++ b/exportacion/Presentacion_Mejora_Pistas_Multideporte.pptx
@@ -10494,11 +10494,11 @@
         <p:spPr>
           <a:xfrm>
             <a:off x="812800" y="1460500"/>
-            <a:ext cx="5181600" cy="3333750"/>
+            <a:ext cx="5181600" cy="3651250"/>
           </a:xfrm>
           <a:prstGeom prst="roundRect">
             <a:avLst>
-              <a:gd name="adj" fmla="val 3809"/>
+              <a:gd name="adj" fmla="val 3478"/>
             </a:avLst>
           </a:prstGeom>
           <a:solidFill>
@@ -10533,7 +10533,7 @@
       </p:sp>
       <p:pic>
         <p:nvPicPr>
-          <p:cNvPr id="5" name="Picture 4" descr="r_atl.jpg"/>
+          <p:cNvPr id="5" name="Picture 4" descr="s_tartan.jpg"/>
           <p:cNvPicPr>
             <a:picLocks noChangeAspect="1"/>
           </p:cNvPicPr>
@@ -10541,7 +10541,7 @@
         </p:nvPicPr>
         <p:blipFill>
           <a:blip r:embed="rId3"/>
-          <a:srcRect t="27306" b="27306"/>
+          <a:srcRect t="2199" b="2199"/>
           <a:stretch>
             <a:fillRect/>
           </a:stretch>
@@ -10549,7 +10549,7 @@
         <p:spPr>
           <a:xfrm>
             <a:off x="812800" y="1460500"/>
-            <a:ext cx="5181600" cy="1270000"/>
+            <a:ext cx="5181600" cy="1587500"/>
           </a:xfrm>
           <a:prstGeom prst="rect">
             <a:avLst/>
@@ -10558,19 +10558,17 @@
       </p:pic>
       <p:sp>
         <p:nvSpPr>
-          <p:cNvPr id="6" name="Rounded Rectangle 5"/>
+          <p:cNvPr id="6" name="Rectangle 5"/>
           <p:cNvSpPr/>
           <p:nvPr/>
         </p:nvSpPr>
         <p:spPr>
           <a:xfrm>
-            <a:off x="1041400" y="2921000"/>
-            <a:ext cx="1270000" cy="279400"/>
-          </a:xfrm>
-          <a:prstGeom prst="roundRect">
-            <a:avLst>
-              <a:gd name="adj" fmla="val 50000"/>
-            </a:avLst>
+            <a:off x="965200" y="5048250"/>
+            <a:ext cx="4876800" cy="63500"/>
+          </a:xfrm>
+          <a:prstGeom prst="rect">
+            <a:avLst/>
           </a:prstGeom>
           <a:solidFill>
             <a:srgbClr val="0E9347"/>
@@ -10604,13 +10602,59 @@
       </p:sp>
       <p:sp>
         <p:nvSpPr>
-          <p:cNvPr id="7" name="TextBox 6"/>
+          <p:cNvPr id="7" name="Rounded Rectangle 6"/>
+          <p:cNvSpPr/>
+          <p:nvPr/>
+        </p:nvSpPr>
+        <p:spPr>
+          <a:xfrm>
+            <a:off x="1041400" y="3238500"/>
+            <a:ext cx="1270000" cy="279400"/>
+          </a:xfrm>
+          <a:prstGeom prst="roundRect">
+            <a:avLst>
+              <a:gd name="adj" fmla="val 50000"/>
+            </a:avLst>
+          </a:prstGeom>
+          <a:solidFill>
+            <a:srgbClr val="0E9347"/>
+          </a:solidFill>
+          <a:ln>
+            <a:noFill/>
+          </a:ln>
+          <a:effectLst/>
+        </p:spPr>
+        <p:style>
+          <a:lnRef idx="1">
+            <a:schemeClr val="accent1"/>
+          </a:lnRef>
+          <a:fillRef idx="3">
+            <a:schemeClr val="accent1"/>
+          </a:fillRef>
+          <a:effectRef idx="2">
+            <a:schemeClr val="accent1"/>
+          </a:effectRef>
+          <a:fontRef idx="minor">
+            <a:schemeClr val="lt1"/>
+          </a:fontRef>
+        </p:style>
+        <p:txBody>
+          <a:bodyPr rtlCol="0" anchor="ctr"/>
+          <a:lstStyle/>
+          <a:p>
+            <a:pPr algn="ctr"/>
+          </a:p>
+        </p:txBody>
+      </p:sp>
+      <p:sp>
+        <p:nvSpPr>
+          <p:cNvPr id="8" name="TextBox 7"/>
           <p:cNvSpPr txBox="1"/>
           <p:nvPr/>
         </p:nvSpPr>
         <p:spPr>
           <a:xfrm>
-            <a:off x="1041400" y="2921000"/>
+            <a:off x="1041400" y="3238500"/>
             <a:ext cx="1270000" cy="279400"/>
           </a:xfrm>
           <a:prstGeom prst="rect">
@@ -10643,13 +10687,13 @@
       </p:sp>
       <p:sp>
         <p:nvSpPr>
-          <p:cNvPr id="8" name="TextBox 7"/>
+          <p:cNvPr id="9" name="TextBox 8"/>
           <p:cNvSpPr txBox="1"/>
           <p:nvPr/>
         </p:nvSpPr>
         <p:spPr>
           <a:xfrm>
-            <a:off x="1041400" y="3289300"/>
+            <a:off x="1041400" y="3606800"/>
             <a:ext cx="4724400" cy="393700"/>
           </a:xfrm>
           <a:prstGeom prst="rect">
@@ -10682,13 +10726,13 @@
       </p:sp>
       <p:sp>
         <p:nvSpPr>
-          <p:cNvPr id="9" name="TextBox 8"/>
+          <p:cNvPr id="10" name="TextBox 9"/>
           <p:cNvSpPr txBox="1"/>
           <p:nvPr/>
         </p:nvSpPr>
         <p:spPr>
           <a:xfrm>
-            <a:off x="1041400" y="3759200"/>
+            <a:off x="1041400" y="4076700"/>
             <a:ext cx="4724400" cy="279400"/>
           </a:xfrm>
           <a:prstGeom prst="rect">
@@ -10721,13 +10765,13 @@
       </p:sp>
       <p:sp>
         <p:nvSpPr>
-          <p:cNvPr id="10" name="TextBox 9"/>
+          <p:cNvPr id="11" name="TextBox 10"/>
           <p:cNvSpPr txBox="1"/>
           <p:nvPr/>
         </p:nvSpPr>
         <p:spPr>
           <a:xfrm>
-            <a:off x="1041400" y="4076700"/>
+            <a:off x="1041400" y="4394200"/>
             <a:ext cx="4724400" cy="279400"/>
           </a:xfrm>
           <a:prstGeom prst="rect">
@@ -10760,13 +10804,13 @@
       </p:sp>
       <p:sp>
         <p:nvSpPr>
-          <p:cNvPr id="11" name="TextBox 10"/>
+          <p:cNvPr id="12" name="TextBox 11"/>
           <p:cNvSpPr txBox="1"/>
           <p:nvPr/>
         </p:nvSpPr>
         <p:spPr>
           <a:xfrm>
-            <a:off x="1041400" y="4394200"/>
+            <a:off x="1041400" y="4711700"/>
             <a:ext cx="4724400" cy="279400"/>
           </a:xfrm>
           <a:prstGeom prst="rect">
@@ -10799,18 +10843,18 @@
       </p:sp>
       <p:sp>
         <p:nvSpPr>
-          <p:cNvPr id="12" name="Rounded Rectangle 11"/>
+          <p:cNvPr id="13" name="Rounded Rectangle 12"/>
           <p:cNvSpPr/>
           <p:nvPr/>
         </p:nvSpPr>
         <p:spPr>
           <a:xfrm>
             <a:off x="6197600" y="1460500"/>
-            <a:ext cx="5181600" cy="3333750"/>
+            <a:ext cx="5181600" cy="3651250"/>
           </a:xfrm>
           <a:prstGeom prst="roundRect">
             <a:avLst>
-              <a:gd name="adj" fmla="val 3809"/>
+              <a:gd name="adj" fmla="val 3478"/>
             </a:avLst>
           </a:prstGeom>
           <a:solidFill>
@@ -10845,7 +10889,7 @@
       </p:sp>
       <p:pic>
         <p:nvPicPr>
-          <p:cNvPr id="13" name="Picture 12" descr="r_cancha.jpg"/>
+          <p:cNvPr id="14" name="Picture 13" descr="s_pvc.jpg"/>
           <p:cNvPicPr>
             <a:picLocks noChangeAspect="1"/>
           </p:cNvPicPr>
@@ -10853,7 +10897,7 @@
         </p:nvPicPr>
         <p:blipFill>
           <a:blip r:embed="rId4"/>
-          <a:srcRect t="27306" b="27306"/>
+          <a:srcRect t="2199" b="2199"/>
           <a:stretch>
             <a:fillRect/>
           </a:stretch>
@@ -10861,7 +10905,7 @@
         <p:spPr>
           <a:xfrm>
             <a:off x="6197600" y="1460500"/>
-            <a:ext cx="5181600" cy="1270000"/>
+            <a:ext cx="5181600" cy="1587500"/>
           </a:xfrm>
           <a:prstGeom prst="rect">
             <a:avLst/>
@@ -10870,19 +10914,17 @@
       </p:pic>
       <p:sp>
         <p:nvSpPr>
-          <p:cNvPr id="14" name="Rounded Rectangle 13"/>
+          <p:cNvPr id="15" name="Rectangle 14"/>
           <p:cNvSpPr/>
           <p:nvPr/>
         </p:nvSpPr>
         <p:spPr>
           <a:xfrm>
-            <a:off x="6426200" y="2921000"/>
-            <a:ext cx="2667000" cy="279400"/>
-          </a:xfrm>
-          <a:prstGeom prst="roundRect">
-            <a:avLst>
-              <a:gd name="adj" fmla="val 50000"/>
-            </a:avLst>
+            <a:off x="6350000" y="5048250"/>
+            <a:ext cx="4876800" cy="63500"/>
+          </a:xfrm>
+          <a:prstGeom prst="rect">
+            <a:avLst/>
           </a:prstGeom>
           <a:solidFill>
             <a:srgbClr val="E8791B"/>
@@ -10916,13 +10958,59 @@
       </p:sp>
       <p:sp>
         <p:nvSpPr>
-          <p:cNvPr id="15" name="TextBox 14"/>
+          <p:cNvPr id="16" name="Rounded Rectangle 15"/>
+          <p:cNvSpPr/>
+          <p:nvPr/>
+        </p:nvSpPr>
+        <p:spPr>
+          <a:xfrm>
+            <a:off x="6426200" y="3238500"/>
+            <a:ext cx="2667000" cy="279400"/>
+          </a:xfrm>
+          <a:prstGeom prst="roundRect">
+            <a:avLst>
+              <a:gd name="adj" fmla="val 50000"/>
+            </a:avLst>
+          </a:prstGeom>
+          <a:solidFill>
+            <a:srgbClr val="E8791B"/>
+          </a:solidFill>
+          <a:ln>
+            <a:noFill/>
+          </a:ln>
+          <a:effectLst/>
+        </p:spPr>
+        <p:style>
+          <a:lnRef idx="1">
+            <a:schemeClr val="accent1"/>
+          </a:lnRef>
+          <a:fillRef idx="3">
+            <a:schemeClr val="accent1"/>
+          </a:fillRef>
+          <a:effectRef idx="2">
+            <a:schemeClr val="accent1"/>
+          </a:effectRef>
+          <a:fontRef idx="minor">
+            <a:schemeClr val="lt1"/>
+          </a:fontRef>
+        </p:style>
+        <p:txBody>
+          <a:bodyPr rtlCol="0" anchor="ctr"/>
+          <a:lstStyle/>
+          <a:p>
+            <a:pPr algn="ctr"/>
+          </a:p>
+        </p:txBody>
+      </p:sp>
+      <p:sp>
+        <p:nvSpPr>
+          <p:cNvPr id="17" name="TextBox 16"/>
           <p:cNvSpPr txBox="1"/>
           <p:nvPr/>
         </p:nvSpPr>
         <p:spPr>
           <a:xfrm>
-            <a:off x="6426200" y="2921000"/>
+            <a:off x="6426200" y="3238500"/>
             <a:ext cx="2667000" cy="279400"/>
           </a:xfrm>
           <a:prstGeom prst="rect">
@@ -10955,13 +11043,13 @@
       </p:sp>
       <p:sp>
         <p:nvSpPr>
-          <p:cNvPr id="16" name="TextBox 15"/>
+          <p:cNvPr id="18" name="TextBox 17"/>
           <p:cNvSpPr txBox="1"/>
           <p:nvPr/>
         </p:nvSpPr>
         <p:spPr>
           <a:xfrm>
-            <a:off x="6426200" y="3289300"/>
+            <a:off x="6426200" y="3606800"/>
             <a:ext cx="4724400" cy="393700"/>
           </a:xfrm>
           <a:prstGeom prst="rect">
@@ -10994,13 +11082,13 @@
       </p:sp>
       <p:sp>
         <p:nvSpPr>
-          <p:cNvPr id="17" name="TextBox 16"/>
+          <p:cNvPr id="19" name="TextBox 18"/>
           <p:cNvSpPr txBox="1"/>
           <p:nvPr/>
         </p:nvSpPr>
         <p:spPr>
           <a:xfrm>
-            <a:off x="6426200" y="3759200"/>
+            <a:off x="6426200" y="4076700"/>
             <a:ext cx="4724400" cy="279400"/>
           </a:xfrm>
           <a:prstGeom prst="rect">
@@ -11033,13 +11121,13 @@
       </p:sp>
       <p:sp>
         <p:nvSpPr>
-          <p:cNvPr id="18" name="TextBox 17"/>
+          <p:cNvPr id="20" name="TextBox 19"/>
           <p:cNvSpPr txBox="1"/>
           <p:nvPr/>
         </p:nvSpPr>
         <p:spPr>
           <a:xfrm>
-            <a:off x="6426200" y="4076700"/>
+            <a:off x="6426200" y="4394200"/>
             <a:ext cx="4724400" cy="279400"/>
           </a:xfrm>
           <a:prstGeom prst="rect">
@@ -11072,13 +11160,13 @@
       </p:sp>
       <p:sp>
         <p:nvSpPr>
-          <p:cNvPr id="19" name="TextBox 18"/>
+          <p:cNvPr id="21" name="TextBox 20"/>
           <p:cNvSpPr txBox="1"/>
           <p:nvPr/>
         </p:nvSpPr>
         <p:spPr>
           <a:xfrm>
-            <a:off x="6426200" y="4394200"/>
+            <a:off x="6426200" y="4711700"/>
             <a:ext cx="4724400" cy="279400"/>
           </a:xfrm>
           <a:prstGeom prst="rect">
@@ -11111,13 +11199,13 @@
       </p:sp>
       <p:sp>
         <p:nvSpPr>
-          <p:cNvPr id="20" name="TextBox 19"/>
+          <p:cNvPr id="22" name="TextBox 21"/>
           <p:cNvSpPr txBox="1"/>
           <p:nvPr/>
         </p:nvSpPr>
         <p:spPr>
           <a:xfrm>
-            <a:off x="812800" y="4972050"/>
+            <a:off x="812800" y="5289550"/>
             <a:ext cx="10566400" cy="317500"/>
           </a:xfrm>
           <a:prstGeom prst="rect">
@@ -11150,13 +11238,13 @@
       </p:sp>
       <p:sp>
         <p:nvSpPr>
-          <p:cNvPr id="21" name="Rounded Rectangle 20"/>
+          <p:cNvPr id="23" name="Rounded Rectangle 22"/>
           <p:cNvSpPr/>
           <p:nvPr/>
         </p:nvSpPr>
         <p:spPr>
           <a:xfrm>
-            <a:off x="812800" y="5372100"/>
+            <a:off x="812800" y="5689600"/>
             <a:ext cx="3282950" cy="419100"/>
           </a:xfrm>
           <a:prstGeom prst="roundRect">
@@ -11196,13 +11284,13 @@
       </p:sp>
       <p:sp>
         <p:nvSpPr>
-          <p:cNvPr id="22" name="TextBox 21"/>
+          <p:cNvPr id="24" name="TextBox 23"/>
           <p:cNvSpPr txBox="1"/>
           <p:nvPr/>
         </p:nvSpPr>
         <p:spPr>
           <a:xfrm>
-            <a:off x="812800" y="5372100"/>
+            <a:off x="812800" y="5689600"/>
             <a:ext cx="3282950" cy="419100"/>
           </a:xfrm>
           <a:prstGeom prst="rect">
@@ -11235,13 +11323,13 @@
       </p:sp>
       <p:sp>
         <p:nvSpPr>
-          <p:cNvPr id="23" name="TextBox 22"/>
+          <p:cNvPr id="25" name="TextBox 24"/>
           <p:cNvSpPr txBox="1"/>
           <p:nvPr/>
         </p:nvSpPr>
         <p:spPr>
           <a:xfrm>
-            <a:off x="4095750" y="5372100"/>
+            <a:off x="4095750" y="5689600"/>
             <a:ext cx="355600" cy="419100"/>
           </a:xfrm>
           <a:prstGeom prst="rect">
@@ -11274,13 +11362,13 @@
       </p:sp>
       <p:sp>
         <p:nvSpPr>
-          <p:cNvPr id="24" name="Rounded Rectangle 23"/>
+          <p:cNvPr id="26" name="Rounded Rectangle 25"/>
           <p:cNvSpPr/>
           <p:nvPr/>
         </p:nvSpPr>
         <p:spPr>
           <a:xfrm>
-            <a:off x="4451350" y="5372100"/>
+            <a:off x="4451350" y="5689600"/>
             <a:ext cx="3282950" cy="419100"/>
           </a:xfrm>
           <a:prstGeom prst="roundRect">
@@ -11320,13 +11408,13 @@
       </p:sp>
       <p:sp>
         <p:nvSpPr>
-          <p:cNvPr id="25" name="TextBox 24"/>
+          <p:cNvPr id="27" name="TextBox 26"/>
           <p:cNvSpPr txBox="1"/>
           <p:nvPr/>
         </p:nvSpPr>
         <p:spPr>
           <a:xfrm>
-            <a:off x="4451350" y="5372100"/>
+            <a:off x="4451350" y="5689600"/>
             <a:ext cx="3282950" cy="419100"/>
           </a:xfrm>
           <a:prstGeom prst="rect">
@@ -11359,13 +11447,13 @@
       </p:sp>
       <p:sp>
         <p:nvSpPr>
-          <p:cNvPr id="26" name="TextBox 25"/>
+          <p:cNvPr id="28" name="TextBox 27"/>
           <p:cNvSpPr txBox="1"/>
           <p:nvPr/>
         </p:nvSpPr>
         <p:spPr>
           <a:xfrm>
-            <a:off x="7734300" y="5372100"/>
+            <a:off x="7734300" y="5689600"/>
             <a:ext cx="355600" cy="419100"/>
           </a:xfrm>
           <a:prstGeom prst="rect">
@@ -11398,13 +11486,13 @@
       </p:sp>
       <p:sp>
         <p:nvSpPr>
-          <p:cNvPr id="27" name="Rounded Rectangle 26"/>
+          <p:cNvPr id="29" name="Rounded Rectangle 28"/>
           <p:cNvSpPr/>
           <p:nvPr/>
         </p:nvSpPr>
         <p:spPr>
           <a:xfrm>
-            <a:off x="8089900" y="5372100"/>
+            <a:off x="8089900" y="5689600"/>
             <a:ext cx="3282950" cy="419100"/>
           </a:xfrm>
           <a:prstGeom prst="roundRect">
@@ -11444,13 +11532,13 @@
       </p:sp>
       <p:sp>
         <p:nvSpPr>
-          <p:cNvPr id="28" name="TextBox 27"/>
+          <p:cNvPr id="30" name="TextBox 29"/>
           <p:cNvSpPr txBox="1"/>
           <p:nvPr/>
         </p:nvSpPr>
         <p:spPr>
           <a:xfrm>
-            <a:off x="8089900" y="5372100"/>
+            <a:off x="8089900" y="5689600"/>
             <a:ext cx="3282950" cy="419100"/>
           </a:xfrm>
           <a:prstGeom prst="rect">
@@ -11483,13 +11571,13 @@
       </p:sp>
       <p:sp>
         <p:nvSpPr>
-          <p:cNvPr id="29" name="TextBox 28"/>
+          <p:cNvPr id="31" name="TextBox 30"/>
           <p:cNvSpPr txBox="1"/>
           <p:nvPr/>
         </p:nvSpPr>
         <p:spPr>
           <a:xfrm>
-            <a:off x="812800" y="5905500"/>
+            <a:off x="812800" y="6223000"/>
             <a:ext cx="10566400" cy="254000"/>
           </a:xfrm>
           <a:prstGeom prst="rect">

</xml_diff>

<commit_message>
Título "Atletismo, bajo cubierta" y superficies con ilustraciones nítidas
- Diapositiva de atletismo: título sin "de verdad"
- Superficies: tartán granulado azul/rojo y PVC verde liso, bien diferenciados
- PowerPoint y PDF (completo y ligero) actualizados

Co-Authored-By: Claude Sonnet 5.5 <noreply@anthropic.com>
</commit_message>
<xml_diff>
--- a/exportacion/Presentacion_Mejora_Pistas_Multideporte.pptx
+++ b/exportacion/Presentacion_Mejora_Pistas_Multideporte.pptx
@@ -9380,7 +9380,7 @@
                 </a:solidFill>
                 <a:latin typeface="Arial Narrow"/>
               </a:rPr>
-              <a:t>ATLETISMO DE VERDAD, BAJO CUBIERTA</a:t>
+              <a:t>ATLETISMO, BAJO CUBIERTA</a:t>
             </a:r>
           </a:p>
         </p:txBody>
@@ -10533,7 +10533,7 @@
       </p:sp>
       <p:pic>
         <p:nvPicPr>
-          <p:cNvPr id="5" name="Picture 4" descr="s_tartan.jpg"/>
+          <p:cNvPr id="5" name="Picture 4" descr="sup_tartan.jpg"/>
           <p:cNvPicPr>
             <a:picLocks noChangeAspect="1"/>
           </p:cNvPicPr>
@@ -10541,7 +10541,7 @@
         </p:nvPicPr>
         <p:blipFill>
           <a:blip r:embed="rId3"/>
-          <a:srcRect t="2199" b="2199"/>
+          <a:srcRect t="1923" b="1923"/>
           <a:stretch>
             <a:fillRect/>
           </a:stretch>
@@ -10889,7 +10889,7 @@
       </p:sp>
       <p:pic>
         <p:nvPicPr>
-          <p:cNvPr id="14" name="Picture 13" descr="s_pvc.jpg"/>
+          <p:cNvPr id="14" name="Picture 13" descr="sup_pvc.jpg"/>
           <p:cNvPicPr>
             <a:picLocks noChangeAspect="1"/>
           </p:cNvPicPr>
@@ -10897,7 +10897,7 @@
         </p:nvPicPr>
         <p:blipFill>
           <a:blip r:embed="rId4"/>
-          <a:srcRect t="2199" b="2199"/>
+          <a:srcRect t="1923" b="1923"/>
           <a:stretch>
             <a:fillRect/>
           </a:stretch>

</xml_diff>